<commit_message>
Confirm Pest Free cross-line ownership in org chart
Pest Free is owned by Shah (Inam's team) with Winnie holding manager
oversight, as confirmed. The note read as an open question; it now
states the arrangement as intended.

- Reword the footnote on all three content slides from "confirm if this
  is intended" to "cross-line by design".
- Tag the Pest Free provider card with a "cross-line" pill and show the
  owner's team inline, so the Shah/Winnie split reads as deliberate
  rather than a mismatch.

Co-Authored-By: Claude Opus 5 <noreply@anthropic.com>
Claude-Session: https://claude.ai/code/session_01WTRSB49vvbaAvoTUTRx5PU
</commit_message>
<xml_diff>
--- a/org-chart/Team_Allocation_Org_Chart.pptx
+++ b/org-chart/Team_Allocation_Org_Chart.pptx
@@ -5506,7 +5506,7 @@
                 <a:ea typeface="Calibri" pitchFamily="34" charset="-122"/>
                 <a:cs typeface="Calibri" pitchFamily="34" charset="-120"/>
               </a:rPr>
-              <a:t>*  Pest Free sits with Shah (Inam's team) but is listed under Winnie for manager oversight in the source allocation — confirm if this is intended.</a:t>
+              <a:t>*  Cross-line by design: Pest Free is owned day to day by Shah (Inam's team), with Winnie holding manager oversight.</a:t>
             </a:r>
             <a:endParaRPr lang="en-US" sz="750" dirty="0"/>
           </a:p>
@@ -7695,7 +7695,7 @@
                 <a:ea typeface="Calibri" pitchFamily="34" charset="-122"/>
                 <a:cs typeface="Calibri" pitchFamily="34" charset="-120"/>
               </a:rPr>
-              <a:t>*  Pest Free sits with Shah (Inam's team) but is listed under Winnie for manager oversight in the source allocation — confirm if this is intended.</a:t>
+              <a:t>*  Cross-line by design: Pest Free is owned day to day by Shah (Inam's team), with Winnie holding manager oversight.</a:t>
             </a:r>
             <a:endParaRPr lang="en-US" sz="700" dirty="0"/>
           </a:p>
@@ -10008,7 +10008,7 @@
         <p:spPr>
           <a:xfrm>
             <a:off x="9537192" y="4096512"/>
-            <a:ext cx="1965960" cy="329184"/>
+            <a:ext cx="1188720" cy="329184"/>
           </a:xfrm>
           <a:prstGeom prst="rect">
             <a:avLst/>
@@ -10046,6 +10046,72 @@
         </p:nvSpPr>
         <p:spPr>
           <a:xfrm>
+            <a:off x="10725912" y="4151376"/>
+            <a:ext cx="777240" cy="219456"/>
+          </a:xfrm>
+          <a:prstGeom prst="roundRect">
+            <a:avLst>
+              <a:gd name="adj" fmla="val 20833"/>
+            </a:avLst>
+          </a:prstGeom>
+          <a:solidFill>
+            <a:srgbClr val="FCF4E3"/>
+          </a:solidFill>
+          <a:ln w="9525">
+            <a:solidFill>
+              <a:srgbClr val="C8912A"/>
+            </a:solidFill>
+            <a:prstDash val="solid"/>
+          </a:ln>
+        </p:spPr>
+      </p:sp>
+      <p:sp>
+        <p:nvSpPr>
+          <p:cNvPr id="69" name="Text 67"/>
+          <p:cNvSpPr/>
+          <p:nvPr/>
+        </p:nvSpPr>
+        <p:spPr>
+          <a:xfrm>
+            <a:off x="10725912" y="4151376"/>
+            <a:ext cx="777240" cy="219456"/>
+          </a:xfrm>
+          <a:prstGeom prst="rect">
+            <a:avLst/>
+          </a:prstGeom>
+          <a:noFill/>
+          <a:ln/>
+        </p:spPr>
+        <p:txBody>
+          <a:bodyPr wrap="square" lIns="0" tIns="0" rIns="0" bIns="0" rtlCol="0" anchor="ctr"/>
+          <a:lstStyle/>
+          <a:p>
+            <a:pPr algn="ctr" indent="0" marL="0">
+              <a:buNone/>
+            </a:pPr>
+            <a:r>
+              <a:rPr lang="en-US" sz="600" b="1" spc="40" kern="0" dirty="0">
+                <a:solidFill>
+                  <a:srgbClr val="8A5C0E"/>
+                </a:solidFill>
+                <a:latin typeface="Calibri" pitchFamily="34" charset="0"/>
+                <a:ea typeface="Calibri" pitchFamily="34" charset="-122"/>
+                <a:cs typeface="Calibri" pitchFamily="34" charset="-120"/>
+              </a:rPr>
+              <a:t>CROSS-LINE</a:t>
+            </a:r>
+            <a:endParaRPr lang="en-US" sz="600" dirty="0"/>
+          </a:p>
+        </p:txBody>
+      </p:sp>
+      <p:sp>
+        <p:nvSpPr>
+          <p:cNvPr id="70" name="Shape 68"/>
+          <p:cNvSpPr/>
+          <p:nvPr/>
+        </p:nvSpPr>
+        <p:spPr>
+          <a:xfrm>
             <a:off x="9299448" y="4498848"/>
             <a:ext cx="2203704" cy="0"/>
           </a:xfrm>
@@ -10063,7 +10129,7 @@
       </p:sp>
       <p:sp>
         <p:nvSpPr>
-          <p:cNvPr id="69" name="Text 67"/>
+          <p:cNvPr id="71" name="Text 69"/>
           <p:cNvSpPr/>
           <p:nvPr/>
         </p:nvSpPr>
@@ -10110,13 +10176,27 @@
               </a:rPr>
               <a:t>Shah</a:t>
             </a:r>
+            <a:pPr indent="0" marL="0">
+              <a:buNone/>
+            </a:pPr>
+            <a:r>
+              <a:rPr lang="en-US" sz="850" dirty="0">
+                <a:solidFill>
+                  <a:srgbClr val="6E7D93"/>
+                </a:solidFill>
+                <a:latin typeface="Calibri" pitchFamily="34" charset="0"/>
+                <a:ea typeface="Calibri" pitchFamily="34" charset="-122"/>
+                <a:cs typeface="Calibri" pitchFamily="34" charset="-120"/>
+              </a:rPr>
+              <a:t>   (Inam's team)</a:t>
+            </a:r>
             <a:endParaRPr lang="en-US" sz="850" dirty="0"/>
           </a:p>
         </p:txBody>
       </p:sp>
       <p:sp>
         <p:nvSpPr>
-          <p:cNvPr id="70" name="Text 68"/>
+          <p:cNvPr id="72" name="Text 70"/>
           <p:cNvSpPr/>
           <p:nvPr/>
         </p:nvSpPr>
@@ -10155,7 +10235,7 @@
       </p:sp>
       <p:sp>
         <p:nvSpPr>
-          <p:cNvPr id="71" name="Shape 69"/>
+          <p:cNvPr id="73" name="Shape 71"/>
           <p:cNvSpPr/>
           <p:nvPr/>
         </p:nvSpPr>
@@ -10182,7 +10262,7 @@
       </p:sp>
       <p:sp>
         <p:nvSpPr>
-          <p:cNvPr id="72" name="Text 70"/>
+          <p:cNvPr id="74" name="Text 72"/>
           <p:cNvSpPr/>
           <p:nvPr/>
         </p:nvSpPr>
@@ -10221,7 +10301,7 @@
       </p:sp>
       <p:sp>
         <p:nvSpPr>
-          <p:cNvPr id="73" name="Shape 71"/>
+          <p:cNvPr id="75" name="Shape 73"/>
           <p:cNvSpPr/>
           <p:nvPr/>
         </p:nvSpPr>
@@ -10248,7 +10328,7 @@
       </p:sp>
       <p:sp>
         <p:nvSpPr>
-          <p:cNvPr id="74" name="Text 72"/>
+          <p:cNvPr id="76" name="Text 74"/>
           <p:cNvSpPr/>
           <p:nvPr/>
         </p:nvSpPr>
@@ -10301,7 +10381,7 @@
       </p:sp>
       <p:sp>
         <p:nvSpPr>
-          <p:cNvPr id="75" name="Text 73"/>
+          <p:cNvPr id="77" name="Text 75"/>
           <p:cNvSpPr/>
           <p:nvPr/>
         </p:nvSpPr>
@@ -10332,7 +10412,7 @@
                 <a:ea typeface="Calibri" pitchFamily="34" charset="-122"/>
                 <a:cs typeface="Calibri" pitchFamily="34" charset="-120"/>
               </a:rPr>
-              <a:t>*  Pest Free sits with Shah (Inam's team) but is listed under Winnie for manager oversight in the source allocation — confirm if this is intended.</a:t>
+              <a:t>*  Cross-line by design: Pest Free is owned day to day by Shah (Inam's team), with Winnie holding manager oversight.</a:t>
             </a:r>
             <a:endParaRPr lang="en-US" sz="750" dirty="0"/>
           </a:p>

</xml_diff>